<commit_message>
Show v2 answer quality on both axes in the pitch deck
Slide 5 now reports both EM (0.52 vs ~0.37) and F1 (0.64 vs ~0.45)
for graph-RLM v2 against public LLM baselines on the full 500 cases.
Speaker notes flag the external comparison as directional (non-identical
MuSiQue protocols) so it is not overclaimed on stage.

Co-Authored-By: Claude Opus 4.8 (1M context) <noreply@anthropic.com>
</commit_message>
<xml_diff>
--- a/docs/graphrlm_pitch.pptx
+++ b/docs/graphrlm_pitch.pptx
@@ -788,7 +788,7 @@
           <a:lstStyle/>
           <a:p>
             <a:r>
-              <a:t>~45 сек. Связка качество+цена. Цифры с полных 500 кейсов — надёжные. Не уходи в F1 против text-RLM (незначимо, n=60). Здесь — только абсолютные числа против внешних бейзлайнов.</a:t>
+              <a:t>~45 сек. Связка качество+цена. Цифры v2 на полных 500 кейсах (EM 0.522, F1 0.639) — надёжные сами по себе. ОСТОРОЖНО: сравнение с публичными LLM — directional (разные протоколы оценки MuSiQue), держи звёздочку и НЕ делай 'в 1.4 раза точнее Gemini' главным лозунгом — грамотный человек спросит про идентичность сеттинга. Не уходи в F1 против text-RLM (незначимо, n=60).</a:t>
             </a:r>
           </a:p>
         </p:txBody>
@@ -4926,7 +4926,7 @@
         </p:nvGraphicFramePr>
         <p:xfrm>
           <a:off x="1280160" y="1920240"/>
-          <a:ext cx="9601200" cy="1371600"/>
+          <a:ext cx="9601200" cy="1828800"/>
         </p:xfrm>
         <a:graphic>
           <a:graphicData uri="http://schemas.openxmlformats.org/drawingml/2006/table">
@@ -4953,7 +4953,7 @@
                           </a:solidFill>
                           <a:latin typeface="Segoe UI"/>
                         </a:rPr>
-                        <a:t>Метрика (500 кейсов, zero-shot)</a:t>
+                        <a:t>Метрика (500 кейсов, zero-shot, v2)</a:t>
                       </a:r>
                     </a:p>
                   </a:txBody>
@@ -5089,6 +5089,77 @@
                     <a:p>
                       <a:pPr algn="l"/>
                       <a:r>
+                        <a:rPr sz="1400" b="1">
+                          <a:solidFill>
+                            <a:srgbClr val="9ADBB4"/>
+                          </a:solidFill>
+                          <a:latin typeface="Segoe UI"/>
+                        </a:rPr>
+                        <a:t>Полнота ответа (F1)</a:t>
+                      </a:r>
+                    </a:p>
+                  </a:txBody>
+                  <a:tcPr marL="109728" marR="109728" marT="36576" marB="36576" anchor="ctr">
+                    <a:solidFill>
+                      <a:srgbClr val="20301F"/>
+                    </a:solidFill>
+                  </a:tcPr>
+                </a:tc>
+                <a:tc>
+                  <a:txBody>
+                    <a:bodyPr wrap="square"/>
+                    <a:lstStyle/>
+                    <a:p>
+                      <a:pPr algn="r"/>
+                      <a:r>
+                        <a:rPr sz="1400" b="1">
+                          <a:solidFill>
+                            <a:srgbClr val="9ADBB4"/>
+                          </a:solidFill>
+                          <a:latin typeface="Segoe UI"/>
+                        </a:rPr>
+                        <a:t>0.64</a:t>
+                      </a:r>
+                    </a:p>
+                  </a:txBody>
+                  <a:tcPr marL="109728" marR="109728" marT="36576" marB="36576" anchor="ctr">
+                    <a:solidFill>
+                      <a:srgbClr val="20301F"/>
+                    </a:solidFill>
+                  </a:tcPr>
+                </a:tc>
+                <a:tc>
+                  <a:txBody>
+                    <a:bodyPr wrap="square"/>
+                    <a:lstStyle/>
+                    <a:p>
+                      <a:pPr algn="r"/>
+                      <a:r>
+                        <a:rPr sz="1400" b="1">
+                          <a:solidFill>
+                            <a:srgbClr val="9ADBB4"/>
+                          </a:solidFill>
+                          <a:latin typeface="Segoe UI"/>
+                        </a:rPr>
+                        <a:t>~0.45</a:t>
+                      </a:r>
+                    </a:p>
+                  </a:txBody>
+                  <a:tcPr marL="109728" marR="109728" marT="36576" marB="36576" anchor="ctr">
+                    <a:solidFill>
+                      <a:srgbClr val="20301F"/>
+                    </a:solidFill>
+                  </a:tcPr>
+                </a:tc>
+              </a:tr>
+              <a:tr h="457200">
+                <a:tc>
+                  <a:txBody>
+                    <a:bodyPr wrap="square"/>
+                    <a:lstStyle/>
+                    <a:p>
+                      <a:pPr algn="l"/>
+                      <a:r>
                         <a:rPr sz="1400" b="0">
                           <a:solidFill>
                             <a:srgbClr val="E8EAF0"/>
@@ -5164,7 +5235,7 @@
         </p:nvSpPr>
         <p:spPr>
           <a:xfrm>
-            <a:off x="822960" y="4206240"/>
+            <a:off x="822960" y="4480560"/>
             <a:ext cx="10515600" cy="2011680"/>
           </a:xfrm>
           <a:prstGeom prst="rect">
@@ -5193,7 +5264,7 @@
                 </a:solidFill>
                 <a:latin typeface="Segoe UI"/>
               </a:rPr>
-              <a:t>•  Точность ответа в 1.4 раза выше публичных LLM-бейзлайнов — на дешёвой модели.</a:t>
+              <a:t>•  Точность и полнота ответа в ~1.4 раза выше публичных LLM-бейзлайнов — на дешёвой модели.</a:t>
             </a:r>
           </a:p>
           <a:p>

</xml_diff>

<commit_message>
Reposition pitch from "measuring completeness" to "delivering the missing fact"
Lead with the active value (retrieve the specific missing evidence link)
while keeping completeness as the differentiator that separates this from
plain RAG - retrieving the link the system knows is missing, not just more
relevant chunks. Title, problem payoff line and solution header reworded;
"меряют" -> "измеряют".

Co-Authored-By: Claude Opus 4.8 (1M context) <noreply@anthropic.com>
</commit_message>
<xml_diff>
--- a/docs/graphrlm_pitch.pptx
+++ b/docs/graphrlm_pitch.pptx
@@ -3998,7 +3998,7 @@
                 </a:solidFill>
                 <a:latin typeface="Segoe UI"/>
               </a:rPr>
-              <a:t>Слой проверки полноты доказательств для AI-research —</a:t>
+              <a:t>Достаёт недостающие звенья доказательной цепочки в контекст AI-research —</a:t>
             </a:r>
           </a:p>
           <a:p>
@@ -4165,7 +4165,7 @@
                 </a:solidFill>
                 <a:latin typeface="Segoe UI"/>
               </a:rPr>
-              <a:t>•  Все меряют точность ответа. Полноту доказательной базы не меряет никто.</a:t>
+              <a:t>•  Все измеряют точность ответа. Полноту доказательной базы — никто.</a:t>
             </a:r>
           </a:p>
           <a:p>
@@ -4226,7 +4226,7 @@
                 </a:solidFill>
                 <a:latin typeface="Segoe UI"/>
               </a:rPr>
-              <a:t>Мы первыми сделали полноту измеримой метрикой — и научились её гарантировать.</a:t>
+              <a:t>Мы не просто измеряем полноту — мы достаём в контекст именно то доказательство, которого не хватает.</a:t>
             </a:r>
           </a:p>
         </p:txBody>
@@ -4294,7 +4294,7 @@
                 </a:solidFill>
                 <a:latin typeface="Segoe UI"/>
               </a:rPr>
-              <a:t>Решение: дешёвый аудит полноты + дорогой поиск по триггеру</a:t>
+              <a:t>Решение: дёшево находим пробел — дорого закрываем, только где он есть</a:t>
             </a:r>
           </a:p>
         </p:txBody>

</xml_diff>